<commit_message>
se actualizó el module_base.json, y también se corrigió el problema de diplomado 2qrs unt)
</commit_message>
<xml_diff>
--- a/app/templates/universidad_2qrs/plantilla_diplomado.pptx
+++ b/app/templates/universidad_2qrs/plantilla_diplomado.pptx
@@ -357,7 +357,7 @@
           <a:p>
             <a:fld id="{03C7FEFC-EB52-44D6-B3F1-2A7BB7FA4226}" type="datetimeFigureOut">
               <a:rPr lang="es-PE" smtClean="0"/>
-              <a:t>7/06/2026</a:t>
+              <a:t>12/06/2026</a:t>
             </a:fld>
             <a:endParaRPr lang="es-PE" dirty="0"/>
           </a:p>
@@ -522,7 +522,7 @@
           <a:p>
             <a:fld id="{64955E78-CBAA-441B-9163-D9CD5E983BDA}" type="datetimeFigureOut">
               <a:rPr lang="en-US" smtClean="0"/>
-              <a:t>6/7/2026</a:t>
+              <a:t>6/12/2026</a:t>
             </a:fld>
             <a:endParaRPr lang="en-US" dirty="0"/>
           </a:p>
@@ -921,7 +921,7 @@
           <a:p>
             <a:fld id="{5C4C4E00-4716-4B48-9D97-535E4F94A274}" type="datetimeFigureOut">
               <a:rPr lang="es-PE" smtClean="0"/>
-              <a:t>7/06/2026</a:t>
+              <a:t>12/06/2026</a:t>
             </a:fld>
             <a:endParaRPr lang="es-PE" dirty="0"/>
           </a:p>
@@ -1091,7 +1091,7 @@
           <a:p>
             <a:fld id="{5C4C4E00-4716-4B48-9D97-535E4F94A274}" type="datetimeFigureOut">
               <a:rPr lang="es-PE" smtClean="0"/>
-              <a:t>7/06/2026</a:t>
+              <a:t>12/06/2026</a:t>
             </a:fld>
             <a:endParaRPr lang="es-PE" dirty="0"/>
           </a:p>
@@ -1271,7 +1271,7 @@
           <a:p>
             <a:fld id="{5C4C4E00-4716-4B48-9D97-535E4F94A274}" type="datetimeFigureOut">
               <a:rPr lang="es-PE" smtClean="0"/>
-              <a:t>7/06/2026</a:t>
+              <a:t>12/06/2026</a:t>
             </a:fld>
             <a:endParaRPr lang="es-PE" dirty="0"/>
           </a:p>
@@ -1441,7 +1441,7 @@
           <a:p>
             <a:fld id="{5C4C4E00-4716-4B48-9D97-535E4F94A274}" type="datetimeFigureOut">
               <a:rPr lang="es-PE" smtClean="0"/>
-              <a:t>7/06/2026</a:t>
+              <a:t>12/06/2026</a:t>
             </a:fld>
             <a:endParaRPr lang="es-PE" dirty="0"/>
           </a:p>
@@ -1685,7 +1685,7 @@
           <a:p>
             <a:fld id="{5C4C4E00-4716-4B48-9D97-535E4F94A274}" type="datetimeFigureOut">
               <a:rPr lang="es-PE" smtClean="0"/>
-              <a:t>7/06/2026</a:t>
+              <a:t>12/06/2026</a:t>
             </a:fld>
             <a:endParaRPr lang="es-PE" dirty="0"/>
           </a:p>
@@ -1917,7 +1917,7 @@
           <a:p>
             <a:fld id="{5C4C4E00-4716-4B48-9D97-535E4F94A274}" type="datetimeFigureOut">
               <a:rPr lang="es-PE" smtClean="0"/>
-              <a:t>7/06/2026</a:t>
+              <a:t>12/06/2026</a:t>
             </a:fld>
             <a:endParaRPr lang="es-PE" dirty="0"/>
           </a:p>
@@ -2284,7 +2284,7 @@
           <a:p>
             <a:fld id="{5C4C4E00-4716-4B48-9D97-535E4F94A274}" type="datetimeFigureOut">
               <a:rPr lang="es-PE" smtClean="0"/>
-              <a:t>7/06/2026</a:t>
+              <a:t>12/06/2026</a:t>
             </a:fld>
             <a:endParaRPr lang="es-PE" dirty="0"/>
           </a:p>
@@ -2402,7 +2402,7 @@
           <a:p>
             <a:fld id="{5C4C4E00-4716-4B48-9D97-535E4F94A274}" type="datetimeFigureOut">
               <a:rPr lang="es-PE" smtClean="0"/>
-              <a:t>7/06/2026</a:t>
+              <a:t>12/06/2026</a:t>
             </a:fld>
             <a:endParaRPr lang="es-PE" dirty="0"/>
           </a:p>
@@ -2497,7 +2497,7 @@
           <a:p>
             <a:fld id="{5C4C4E00-4716-4B48-9D97-535E4F94A274}" type="datetimeFigureOut">
               <a:rPr lang="es-PE" smtClean="0"/>
-              <a:t>7/06/2026</a:t>
+              <a:t>12/06/2026</a:t>
             </a:fld>
             <a:endParaRPr lang="es-PE" dirty="0"/>
           </a:p>
@@ -2774,7 +2774,7 @@
           <a:p>
             <a:fld id="{5C4C4E00-4716-4B48-9D97-535E4F94A274}" type="datetimeFigureOut">
               <a:rPr lang="es-PE" smtClean="0"/>
-              <a:t>7/06/2026</a:t>
+              <a:t>12/06/2026</a:t>
             </a:fld>
             <a:endParaRPr lang="es-PE" dirty="0"/>
           </a:p>
@@ -3031,7 +3031,7 @@
           <a:p>
             <a:fld id="{5C4C4E00-4716-4B48-9D97-535E4F94A274}" type="datetimeFigureOut">
               <a:rPr lang="es-PE" smtClean="0"/>
-              <a:t>7/06/2026</a:t>
+              <a:t>12/06/2026</a:t>
             </a:fld>
             <a:endParaRPr lang="es-PE" dirty="0"/>
           </a:p>
@@ -3244,7 +3244,7 @@
           <a:p>
             <a:fld id="{5C4C4E00-4716-4B48-9D97-535E4F94A274}" type="datetimeFigureOut">
               <a:rPr lang="es-PE" smtClean="0"/>
-              <a:t>7/06/2026</a:t>
+              <a:t>12/06/2026</a:t>
             </a:fld>
             <a:endParaRPr lang="es-PE" dirty="0"/>
           </a:p>
@@ -4431,17 +4431,6 @@
               </a:spcBef>
             </a:pPr>
             <a:r>
-              <a:rPr lang="es-PE" sz="1400">
-                <a:solidFill>
-                  <a:prstClr val="black"/>
-                </a:solidFill>
-                <a:latin typeface="Times New Roman" panose="02020603050405020304" pitchFamily="18" charset="0"/>
-                <a:ea typeface="Cambria Math" panose="02040503050406030204" pitchFamily="18" charset="0"/>
-                <a:cs typeface="Times New Roman" panose="02020603050405020304" pitchFamily="18" charset="0"/>
-              </a:rPr>
-              <a:t>                                                                            {{</a:t>
-            </a:r>
-            <a:r>
               <a:rPr lang="es-PE" sz="1400" dirty="0">
                 <a:solidFill>
                   <a:prstClr val="black"/>
@@ -4450,7 +4439,7 @@
                 <a:ea typeface="Cambria Math" panose="02040503050406030204" pitchFamily="18" charset="0"/>
                 <a:cs typeface="Times New Roman" panose="02020603050405020304" pitchFamily="18" charset="0"/>
               </a:rPr>
-              <a:t>CIUDAD}}, {{FECHA_EMISION_LARGA}}</a:t>
+              <a:t>                                                                            {{CIUDAD}}, {{FECHA_EMISION_LARGA}}</a:t>
             </a:r>
             <a:endParaRPr lang="en-US" sz="1400" dirty="0">
               <a:solidFill>

</xml_diff>